<commit_message>
Export PowerPoint PR4 : retrait de la diapositive TAF et NC (fichier modele envoye seulement pour la forme) - 11 diapositives, plus aucune lecture NC/TAF
Co-Authored-By: Claude Sonnet 5.5 <noreply@anthropic.com>
</commit_message>
<xml_diff>
--- a/assets/pptx/revue-processus-pr4-modele.pptx
+++ b/assets/pptx/revue-processus-pr4-modele.pptx
@@ -15,7 +15,6 @@
     <p:sldId id="259" r:id="rId6"/>
     <p:sldId id="263" r:id="rId7"/>
     <p:sldId id="264" r:id="rId8"/>
-    <p:sldId id="266" r:id="rId9"/>
     <p:sldId id="260" r:id="rId10"/>
     <p:sldId id="261" r:id="rId11"/>
     <p:sldId id="262" r:id="rId12"/>
@@ -9239,124 +9238,6 @@
 </p:sld>
 </file>
 
-<file path=ppt/slides/slide8.xml><?xml version="1.0" encoding="utf-8"?>
-<p:sld xmlns:a="http://schemas.openxmlformats.org/drawingml/2006/main" xmlns:r="http://schemas.openxmlformats.org/officeDocument/2006/relationships" xmlns:p="http://schemas.openxmlformats.org/presentationml/2006/main">
-  <p:cSld>
-    <p:spTree>
-      <p:nvGrpSpPr>
-        <p:cNvPr id="1" name=""/>
-        <p:cNvGrpSpPr/>
-        <p:nvPr/>
-      </p:nvGrpSpPr>
-      <p:grpSpPr>
-        <a:xfrm>
-          <a:off x="0" y="0"/>
-          <a:ext cx="0" cy="0"/>
-          <a:chOff x="0" y="0"/>
-          <a:chExt cx="0" cy="0"/>
-        </a:xfrm>
-      </p:grpSpPr>
-      <p:sp>
-        <p:nvSpPr>
-          <p:cNvPr id="2" name="Title 1">
-            <a:extLst>
-              <a:ext uri="{FF2B5EF4-FFF2-40B4-BE49-F238E27FC236}">
-                <a16:creationId xmlns:a16="http://schemas.microsoft.com/office/drawing/2014/main" id="{AAA1FA81-6CD9-F469-89B1-FC879A9D778E}"/>
-              </a:ext>
-            </a:extLst>
-          </p:cNvPr>
-          <p:cNvSpPr>
-            <a:spLocks noGrp="1"/>
-          </p:cNvSpPr>
-          <p:nvPr>
-            <p:ph type="title"/>
-          </p:nvPr>
-        </p:nvSpPr>
-        <p:spPr/>
-        <p:txBody>
-          <a:bodyPr/>
-          <a:lstStyle/>
-          <a:p>
-            <a:r>
-              <a:rPr lang="en-US" dirty="0"/>
-              <a:t>TAF et NC </a:t>
-            </a:r>
-          </a:p>
-        </p:txBody>
-      </p:sp>
-      <p:pic>
-        <p:nvPicPr>
-          <p:cNvPr id="6" name="Picture 5">
-            <a:extLst>
-              <a:ext uri="{FF2B5EF4-FFF2-40B4-BE49-F238E27FC236}">
-                <a16:creationId xmlns:a16="http://schemas.microsoft.com/office/drawing/2014/main" id="{78B2B924-BCAC-BE2D-834A-7FBC5EAEF6AC}"/>
-              </a:ext>
-            </a:extLst>
-          </p:cNvPr>
-          <p:cNvPicPr>
-            <a:picLocks noChangeAspect="1"/>
-          </p:cNvPicPr>
-          <p:nvPr/>
-        </p:nvPicPr>
-        <p:blipFill>
-          <a:blip r:embed="rId2"/>
-          <a:stretch>
-            <a:fillRect/>
-          </a:stretch>
-        </p:blipFill>
-        <p:spPr>
-          <a:xfrm>
-            <a:off x="15018" y="1338225"/>
-            <a:ext cx="9676384" cy="1184349"/>
-          </a:xfrm>
-          <a:prstGeom prst="rect">
-            <a:avLst/>
-          </a:prstGeom>
-        </p:spPr>
-      </p:pic>
-      <p:pic>
-        <p:nvPicPr>
-          <p:cNvPr id="9" name="Picture 8">
-            <a:extLst>
-              <a:ext uri="{FF2B5EF4-FFF2-40B4-BE49-F238E27FC236}">
-                <a16:creationId xmlns:a16="http://schemas.microsoft.com/office/drawing/2014/main" id="{DD341C20-A434-FFB3-2D7B-55BBB5263DCE}"/>
-              </a:ext>
-            </a:extLst>
-          </p:cNvPr>
-          <p:cNvPicPr>
-            <a:picLocks noChangeAspect="1"/>
-          </p:cNvPicPr>
-          <p:nvPr/>
-        </p:nvPicPr>
-        <p:blipFill>
-          <a:blip r:embed="rId3"/>
-          <a:stretch>
-            <a:fillRect/>
-          </a:stretch>
-        </p:blipFill>
-        <p:spPr>
-          <a:xfrm>
-            <a:off x="697742" y="4263866"/>
-            <a:ext cx="8310935" cy="1611817"/>
-          </a:xfrm>
-          <a:prstGeom prst="rect">
-            <a:avLst/>
-          </a:prstGeom>
-        </p:spPr>
-      </p:pic>
-    </p:spTree>
-    <p:extLst>
-      <p:ext uri="{BB962C8B-B14F-4D97-AF65-F5344CB8AC3E}">
-        <p14:creationId xmlns:p14="http://schemas.microsoft.com/office/powerpoint/2010/main" val="3320024468"/>
-      </p:ext>
-    </p:extLst>
-  </p:cSld>
-  <p:clrMapOvr>
-    <a:masterClrMapping/>
-  </p:clrMapOvr>
-</p:sld>
-</file>
-
 <file path=ppt/slides/slide9.xml><?xml version="1.0" encoding="utf-8"?>
 <p:sld xmlns:a="http://schemas.openxmlformats.org/drawingml/2006/main" xmlns:r="http://schemas.openxmlformats.org/officeDocument/2006/relationships" xmlns:p="http://schemas.openxmlformats.org/presentationml/2006/main">
   <p:cSld>

</xml_diff>